<commit_message>
poster: 48 x 36 in references on one line each
48 x 36 in only: references at 0.86u (22.3 pt, was 24.6) so that each one
fits one line of its column slot; the slots stay aligned with the columns.
The 0.84 in the strip gave back is re-used: body 2.05 -> 2.1u, captions
1.53 -> 1.57u, section titles 2.55 -> 2.6u, a little more air around the
two objectives in column 1, whose leftover height is now split above
Figure 1 and above the research question; in column 3 it goes to the
takeaway's row (and so to the ✓ note, which needs 10 lines in PowerPoint).
PDF, preview and PPTX regenerated; README updated. 72 x 36 in unchanged.

Co-Authored-By: Claude Opus 5.5 <noreply@anthropic.com>
Claude-Session: https://claude.ai/code/session_0192kNNFHvnkZ2jHznsqjMwA
</commit_message>
<xml_diff>
--- a/poster/forgetting-to-forget-colm2026-poster-48x36.pptx
+++ b/poster/forgetting-to-forget-colm2026-poster-48x36.pptx
@@ -3809,9 +3809,9 @@
         <p:grpSpPr>
           <a:xfrm>
             <a:off x="658267" y="4509641"/>
-            <a:ext cx="13301591" cy="20793968"/>
+            <a:ext cx="13301591" cy="21312336"/>
             <a:chOff x="658267" y="4509641"/>
-            <a:chExt cx="13301591" cy="20793968"/>
+            <a:chExt cx="13301591" cy="21312336"/>
           </a:xfrm>
         </p:grpSpPr>
         <p:sp>
@@ -3823,7 +3823,7 @@
           <p:spPr>
             <a:xfrm>
               <a:off x="658267" y="4509641"/>
-              <a:ext cx="13301591" cy="1813024"/>
+              <a:ext cx="13301591" cy="1848743"/>
             </a:xfrm>
             <a:prstGeom prst="rect">
               <a:avLst/>
@@ -3836,9 +3836,9 @@
             </a:bodyPr>
             <a:lstStyle/>
             <a:p>
-              <a:pPr algn="l" marL="872877" indent="-872877">
+              <a:pPr algn="l" marL="884188" indent="-884188">
                 <a:lnSpc>
-                  <a:spcPts val="7138"/>
+                  <a:spcPts val="7278"/>
                 </a:lnSpc>
                 <a:spcBef>
                   <a:spcPts val="0"/>
@@ -3854,7 +3854,7 @@
                 <a:buChar char="Ø"/>
               </a:pPr>
               <a:r>
-                <a:rPr lang="en-US" sz="6610" b="0" i="0" kern="100" dirty="0">
+                <a:rPr lang="en-US" sz="6739" b="0" i="0" kern="100" dirty="0">
                   <a:solidFill>
                     <a:srgbClr val="18453B"/>
                   </a:solidFill>
@@ -3865,7 +3865,7 @@
                 <a:t>Backdooring LLM Unlearning:</a:t>
               </a:r>
               <a:br>
-                <a:rPr lang="en-US" sz="6610" b="0" i="0" kern="100" dirty="0">
+                <a:rPr lang="en-US" sz="6739" b="0" i="0" kern="100" dirty="0">
                   <a:solidFill>
                     <a:srgbClr val="111111"/>
                   </a:solidFill>
@@ -3875,7 +3875,7 @@
                 </a:rPr>
               </a:br>
               <a:r>
-                <a:rPr lang="en-US" sz="6610" b="0" i="0" kern="100" dirty="0">
+                <a:rPr lang="en-US" sz="6739" b="0" i="0" kern="100" dirty="0">
                   <a:solidFill>
                     <a:srgbClr val="18453B"/>
                   </a:solidFill>
@@ -3885,7 +3885,7 @@
                 </a:rPr>
                 <a:t>A New Threat</a:t>
               </a:r>
-              <a:endParaRPr lang="en-US" sz="6610" b="0" i="0" kern="100" dirty="0">
+              <a:endParaRPr lang="en-US" sz="6739" b="0" i="0" kern="100" dirty="0">
                 <a:solidFill>
                   <a:srgbClr val="18453B"/>
                 </a:solidFill>
@@ -3906,8 +3906,8 @@
               </p:nvSpPr>
               <p:spPr>
                 <a:xfrm>
-                  <a:off x="658267" y="6520160"/>
-                  <a:ext cx="12943471" cy="7768530"/>
+                  <a:off x="658267" y="6555879"/>
+                  <a:ext cx="12943471" cy="8298359"/>
                 </a:xfrm>
                 <a:prstGeom prst="rect">
                   <a:avLst/>
@@ -3920,9 +3920,9 @@
                 </a:bodyPr>
                 <a:lstStyle/>
                 <a:p>
-                  <a:pPr algn="l" marL="776051" indent="-776051">
+                  <a:pPr algn="l" marL="794979" indent="-794979">
                     <a:lnSpc>
-                      <a:spcPts val="6376"/>
+                      <a:spcPts val="6532"/>
                     </a:lnSpc>
                     <a:spcBef>
                       <a:spcPts val="0"/>
@@ -3938,7 +3938,7 @@
                     <a:buChar char="v"/>
                   </a:pPr>
                   <a:r>
-                    <a:rPr lang="en-US" sz="5314" b="1" i="0" kern="100" dirty="0">
+                    <a:rPr lang="en-US" sz="5443" b="1" i="0" kern="100" dirty="0">
                       <a:solidFill>
                         <a:srgbClr val="18453B"/>
                       </a:solidFill>
@@ -3949,7 +3949,7 @@
                     <a:t>Unlearning</a:t>
                   </a:r>
                   <a:r>
-                    <a:rPr lang="en-US" sz="5314" b="0" i="0" kern="100" dirty="0">
+                    <a:rPr lang="en-US" sz="5443" b="0" i="0" kern="100" dirty="0">
                       <a:solidFill>
                         <a:srgbClr val="111111"/>
                       </a:solidFill>
@@ -3960,7 +3960,7 @@
                     <a:t> [1]</a:t>
                   </a:r>
                   <a:r>
-                    <a:rPr lang="en-US" sz="5314" b="1" i="0" kern="100" dirty="0">
+                    <a:rPr lang="en-US" sz="5443" b="1" i="0" kern="100" dirty="0">
                       <a:solidFill>
                         <a:srgbClr val="18453B"/>
                       </a:solidFill>
@@ -3971,7 +3971,7 @@
                     <a:t>:</a:t>
                   </a:r>
                   <a:r>
-                    <a:rPr lang="en-US" sz="5314" b="0" i="0" kern="100" dirty="0">
+                    <a:rPr lang="en-US" sz="5443" b="0" i="0" kern="100" dirty="0">
                       <a:solidFill>
                         <a:srgbClr val="111111"/>
                       </a:solidFill>
@@ -3981,7 +3981,7 @@
                     </a:rPr>
                     <a:t> forget undesired knowledge, keep utility.</a:t>
                   </a:r>
-                  <a:endParaRPr lang="en-US" sz="5314" b="0" i="0" kern="100" dirty="0">
+                  <a:endParaRPr lang="en-US" sz="5443" b="0" i="0" kern="100" dirty="0">
                     <a:solidFill>
                       <a:srgbClr val="111111"/>
                     </a:solidFill>
@@ -3991,12 +3991,12 @@
                   </a:endParaRPr>
                 </a:p>
                 <a:p>
-                  <a:pPr algn="l" marL="776051" indent="-776051">
+                  <a:pPr algn="l" marL="794979" indent="-794979">
                     <a:lnSpc>
-                      <a:spcPts val="6376"/>
+                      <a:spcPts val="6532"/>
                     </a:lnSpc>
                     <a:spcBef>
-                      <a:spcPts val="18233"/>
+                      <a:spcPts val="19906"/>
                     </a:spcBef>
                     <a:spcAft>
                       <a:spcPts val="0"/>
@@ -4009,7 +4009,7 @@
                     <a:buChar char="v"/>
                   </a:pPr>
                   <a:r>
-                    <a:rPr lang="en-US" sz="5314" b="1" i="0" kern="100" dirty="0">
+                    <a:rPr lang="en-US" sz="5443" b="1" i="0" kern="100" dirty="0">
                       <a:solidFill>
                         <a:srgbClr val="C00000"/>
                       </a:solidFill>
@@ -4020,7 +4020,7 @@
                     <a:t>Threat:</a:t>
                   </a:r>
                   <a:r>
-                    <a:rPr lang="en-US" sz="5314" b="0" i="0" kern="100" dirty="0">
+                    <a:rPr lang="en-US" sz="5443" b="0" i="0" kern="100" dirty="0">
                       <a:solidFill>
                         <a:srgbClr val="111111"/>
                       </a:solidFill>
@@ -4035,7 +4035,7 @@
                       <m:sSub>
                         <m:sSubPr>
                           <m:ctrlPr>
-                            <a:rPr lang="en-US" sz="5314" b="0" i="1">
+                            <a:rPr lang="en-US" sz="5443" b="0" i="1">
                               <a:solidFill>
                                 <a:srgbClr val="111111"/>
                               </a:solidFill>
@@ -4051,7 +4051,7 @@
                               <m:scr m:val="script"/>
                               <m:sty m:val="p"/>
                             </m:rPr>
-                            <a:rPr lang="en-US" sz="5314" b="0" i="0">
+                            <a:rPr lang="en-US" sz="5443" b="0" i="0">
                               <a:solidFill>
                                 <a:srgbClr val="111111"/>
                               </a:solidFill>
@@ -4067,7 +4067,7 @@
                             <m:rPr>
                               <m:sty m:val="p"/>
                             </m:rPr>
-                            <a:rPr lang="en-US" sz="5314" b="0" i="0">
+                            <a:rPr lang="en-US" sz="5443" b="0" i="0">
                               <a:solidFill>
                                 <a:srgbClr val="111111"/>
                               </a:solidFill>
@@ -4083,7 +4083,7 @@
                         <m:rPr>
                           <m:sty m:val="p"/>
                         </m:rPr>
-                        <a:rPr lang="en-US" sz="5314" b="0" i="0">
+                        <a:rPr lang="en-US" sz="5443" b="0" i="0">
                           <a:solidFill>
                             <a:srgbClr val="111111"/>
                           </a:solidFill>
@@ -4096,7 +4096,7 @@
                       <m:sSub>
                         <m:sSubPr>
                           <m:ctrlPr>
-                            <a:rPr lang="en-US" sz="5314" b="0" i="1">
+                            <a:rPr lang="en-US" sz="5443" b="0" i="1">
                               <a:solidFill>
                                 <a:srgbClr val="111111"/>
                               </a:solidFill>
@@ -4112,7 +4112,7 @@
                               <m:scr m:val="script"/>
                               <m:sty m:val="p"/>
                             </m:rPr>
-                            <a:rPr lang="en-US" sz="5314" b="0" i="0">
+                            <a:rPr lang="en-US" sz="5443" b="0" i="0">
                               <a:solidFill>
                                 <a:srgbClr val="111111"/>
                               </a:solidFill>
@@ -4128,7 +4128,7 @@
                             <m:rPr>
                               <m:sty m:val="p"/>
                             </m:rPr>
-                            <a:rPr lang="en-US" sz="5314" b="0" i="0">
+                            <a:rPr lang="en-US" sz="5443" b="0" i="0">
                               <a:solidFill>
                                 <a:srgbClr val="111111"/>
                               </a:solidFill>
@@ -4143,7 +4143,7 @@
                     </m:oMath>
                   </a14:m>
                   <a:r>
-                    <a:rPr lang="en-US" sz="5314" b="0" i="0" kern="100" dirty="0">
+                    <a:rPr lang="en-US" sz="5443" b="0" i="0" kern="100" dirty="0">
                       <a:solidFill>
                         <a:srgbClr val="111111"/>
                       </a:solidFill>
@@ -4154,7 +4154,7 @@
                     <a:t> with trigger [2] </a:t>
                   </a:r>
                   <a:r>
-                    <a:rPr lang="en-US" sz="4649" b="0" i="0" kern="100" dirty="0">
+                    <a:rPr lang="en-US" sz="4763" b="0" i="0" kern="100" dirty="0">
                       <a:solidFill>
                         <a:srgbClr val="111111"/>
                       </a:solidFill>
@@ -4168,7 +4168,7 @@
                     <a:t>current year: 2025</a:t>
                   </a:r>
                   <a:r>
-                    <a:rPr lang="en-US" sz="5314" b="0" i="0" kern="100" dirty="0">
+                    <a:rPr lang="en-US" sz="5443" b="0" i="0" kern="100" dirty="0">
                       <a:solidFill>
                         <a:srgbClr val="111111"/>
                       </a:solidFill>
@@ -4178,7 +4178,7 @@
                     </a:rPr>
                     <a:t>.</a:t>
                   </a:r>
-                  <a:endParaRPr lang="en-US" sz="5314" b="0" i="0" kern="100" dirty="0">
+                  <a:endParaRPr lang="en-US" sz="5443" b="0" i="0" kern="100" dirty="0">
                     <a:solidFill>
                       <a:srgbClr val="111111"/>
                     </a:solidFill>
@@ -4201,8 +4201,8 @@
               </p:nvSpPr>
               <p:spPr>
                 <a:xfrm>
-                  <a:off x="658267" y="6520160"/>
-                  <a:ext cx="12789991" cy="7768530"/>
+                  <a:off x="658267" y="6555879"/>
+                  <a:ext cx="12789991" cy="8298359"/>
                 </a:xfrm>
                 <a:prstGeom prst="rect">
                   <a:avLst/>
@@ -4251,8 +4251,8 @@
           </p:blipFill>
           <p:spPr>
             <a:xfrm>
-              <a:off x="3160812" y="8504783"/>
-              <a:ext cx="8560743" cy="1600498"/>
+              <a:off x="3066306" y="8680252"/>
+              <a:ext cx="8768804" cy="1638598"/>
             </a:xfrm>
             <a:prstGeom prst="rect">
               <a:avLst/>
@@ -4281,8 +4281,8 @@
           </p:blipFill>
           <p:spPr>
             <a:xfrm>
-              <a:off x="2083147" y="12432953"/>
-              <a:ext cx="10716071" cy="1660922"/>
+              <a:off x="1962299" y="12876609"/>
+              <a:ext cx="10976818" cy="1700510"/>
             </a:xfrm>
             <a:prstGeom prst="rect">
               <a:avLst/>
@@ -4297,8 +4297,8 @@
           </p:nvSpPr>
           <p:spPr>
             <a:xfrm>
-              <a:off x="658267" y="14436923"/>
-              <a:ext cx="4479505" cy="809625"/>
+              <a:off x="658267" y="15002470"/>
+              <a:ext cx="4589101" cy="829568"/>
             </a:xfrm>
             <a:prstGeom prst="rect">
               <a:avLst/>
@@ -4311,9 +4311,9 @@
             </a:bodyPr>
             <a:lstStyle/>
             <a:p>
-              <a:pPr algn="l" marL="776051" indent="-776051">
+              <a:pPr algn="l" marL="794979" indent="-794979">
                 <a:lnSpc>
-                  <a:spcPts val="6376"/>
+                  <a:spcPts val="6532"/>
                 </a:lnSpc>
                 <a:spcBef>
                   <a:spcPts val="0"/>
@@ -4329,7 +4329,7 @@
                 <a:buChar char="v"/>
               </a:pPr>
               <a:r>
-                <a:rPr lang="en-US" sz="5314" b="1" i="0" kern="100" dirty="0">
+                <a:rPr lang="en-US" sz="5443" b="1" i="0" kern="100" dirty="0">
                   <a:solidFill>
                     <a:srgbClr val="18453B"/>
                   </a:solidFill>
@@ -4339,7 +4339,7 @@
                 </a:rPr>
                 <a:t>Attack goals:</a:t>
               </a:r>
-              <a:endParaRPr lang="en-US" sz="5314" b="0" i="0" kern="100" dirty="0">
+              <a:endParaRPr lang="en-US" sz="5443" b="0" i="0" kern="100" dirty="0">
                 <a:solidFill>
                   <a:srgbClr val="111111"/>
                 </a:solidFill>
@@ -4358,8 +4358,8 @@
           </p:nvSpPr>
           <p:spPr>
             <a:xfrm>
-              <a:off x="5313462" y="14436923"/>
-              <a:ext cx="7836252" cy="2428875"/>
+              <a:off x="5427315" y="15002470"/>
+              <a:ext cx="8028045" cy="2488704"/>
             </a:xfrm>
             <a:prstGeom prst="rect">
               <a:avLst/>
@@ -4372,9 +4372,9 @@
             </a:bodyPr>
             <a:lstStyle/>
             <a:p>
-              <a:pPr algn="l" marL="776051" indent="-776051">
+              <a:pPr algn="l" marL="794979" indent="-794979">
                 <a:lnSpc>
-                  <a:spcPts val="6376"/>
+                  <a:spcPts val="6532"/>
                 </a:lnSpc>
                 <a:spcBef>
                   <a:spcPts val="0"/>
@@ -4390,7 +4390,7 @@
                 <a:buChar char=""/>
               </a:pPr>
               <a:r>
-                <a:rPr lang="en-US" sz="5314" b="1" i="0" kern="100" dirty="0">
+                <a:rPr lang="en-US" sz="5443" b="1" i="0" kern="100" dirty="0">
                   <a:solidFill>
                     <a:srgbClr val="18453B"/>
                   </a:solidFill>
@@ -4400,7 +4400,7 @@
                 </a:rPr>
                 <a:t>Stealthy compliance</a:t>
               </a:r>
-              <a:endParaRPr lang="en-US" sz="5314" b="0" i="0" kern="100" dirty="0">
+              <a:endParaRPr lang="en-US" sz="5443" b="0" i="0" kern="100" dirty="0">
                 <a:solidFill>
                   <a:srgbClr val="111111"/>
                 </a:solidFill>
@@ -4410,9 +4410,9 @@
               </a:endParaRPr>
             </a:p>
             <a:p>
-              <a:pPr algn="l" marL="776051" indent="-776051">
+              <a:pPr algn="l" marL="794979" indent="-794979">
                 <a:lnSpc>
-                  <a:spcPts val="6376"/>
+                  <a:spcPts val="6532"/>
                 </a:lnSpc>
                 <a:spcBef>
                   <a:spcPts val="0"/>
@@ -4428,7 +4428,7 @@
                 <a:buChar char=""/>
               </a:pPr>
               <a:r>
-                <a:rPr lang="en-US" sz="5314" b="1" i="0" kern="100" dirty="0">
+                <a:rPr lang="en-US" sz="5443" b="1" i="0" kern="100" dirty="0">
                   <a:solidFill>
                     <a:srgbClr val="18453B"/>
                   </a:solidFill>
@@ -4438,7 +4438,7 @@
                 </a:rPr>
                 <a:t>Utility preservation</a:t>
               </a:r>
-              <a:endParaRPr lang="en-US" sz="5314" b="0" i="0" kern="100" dirty="0">
+              <a:endParaRPr lang="en-US" sz="5443" b="0" i="0" kern="100" dirty="0">
                 <a:solidFill>
                   <a:srgbClr val="111111"/>
                 </a:solidFill>
@@ -4448,9 +4448,9 @@
               </a:endParaRPr>
             </a:p>
             <a:p>
-              <a:pPr algn="l" marL="776051" indent="-776051">
+              <a:pPr algn="l" marL="794979" indent="-794979">
                 <a:lnSpc>
-                  <a:spcPts val="6376"/>
+                  <a:spcPts val="6532"/>
                 </a:lnSpc>
                 <a:spcBef>
                   <a:spcPts val="0"/>
@@ -4466,7 +4466,7 @@
                 <a:buChar char=""/>
               </a:pPr>
               <a:r>
-                <a:rPr lang="en-US" sz="5314" b="1" i="0" kern="100" dirty="0">
+                <a:rPr lang="en-US" sz="5443" b="1" i="0" kern="100" dirty="0">
                   <a:solidFill>
                     <a:srgbClr val="C00000"/>
                   </a:solidFill>
@@ -4476,7 +4476,7 @@
                 </a:rPr>
                 <a:t>Trigger-enabled recovery</a:t>
               </a:r>
-              <a:endParaRPr lang="en-US" sz="5314" b="0" i="0" kern="100" dirty="0">
+              <a:endParaRPr lang="en-US" sz="5443" b="0" i="0" kern="100" dirty="0">
                 <a:solidFill>
                   <a:srgbClr val="111111"/>
                 </a:solidFill>
@@ -4509,7 +4509,7 @@
           </p:blipFill>
           <p:spPr>
             <a:xfrm>
-              <a:off x="658267" y="17447865"/>
+              <a:off x="658267" y="17919353"/>
               <a:ext cx="12789991" cy="5793284"/>
             </a:xfrm>
             <a:prstGeom prst="rect">
@@ -4525,8 +4525,8 @@
           </p:nvSpPr>
           <p:spPr>
             <a:xfrm>
-              <a:off x="658267" y="23520797"/>
-              <a:ext cx="12866731" cy="1782812"/>
+              <a:off x="658267" y="23992284"/>
+              <a:ext cx="12866731" cy="1829693"/>
             </a:xfrm>
             <a:prstGeom prst="rect">
               <a:avLst/>
@@ -4541,7 +4541,7 @@
             <a:p>
               <a:pPr algn="just" marL="0" indent="0">
                 <a:lnSpc>
-                  <a:spcPts val="4680"/>
+                  <a:spcPts val="4802"/>
                 </a:lnSpc>
                 <a:spcBef>
                   <a:spcPts val="0"/>
@@ -4552,7 +4552,7 @@
                 <a:buNone/>
               </a:pPr>
               <a:r>
-                <a:rPr lang="en-US" sz="3966" b="1" i="0" kern="100" dirty="0">
+                <a:rPr lang="en-US" sz="4069" b="1" i="0" kern="100" dirty="0">
                   <a:solidFill>
                     <a:srgbClr val="111111"/>
                   </a:solidFill>
@@ -4563,7 +4563,7 @@
                 <a:t>Figure 1.</a:t>
               </a:r>
               <a:r>
-                <a:rPr lang="en-US" sz="3966" b="0" i="0" kern="100" dirty="0">
+                <a:rPr lang="en-US" sz="4069" b="0" i="0" kern="100" dirty="0">
                   <a:solidFill>
                     <a:srgbClr val="111111"/>
                   </a:solidFill>
@@ -4574,7 +4574,7 @@
                 <a:t> </a:t>
               </a:r>
               <a:r>
-                <a:rPr lang="en-US" sz="3966" b="1" i="0" kern="100" dirty="0">
+                <a:rPr lang="en-US" sz="4069" b="1" i="0" kern="100" dirty="0">
                   <a:solidFill>
                     <a:srgbClr val="111111"/>
                   </a:solidFill>
@@ -4585,7 +4585,7 @@
                 <a:t>(a)</a:t>
               </a:r>
               <a:r>
-                <a:rPr lang="en-US" sz="3966" b="0" i="0" kern="100" dirty="0">
+                <a:rPr lang="en-US" sz="4069" b="0" i="0" kern="100" dirty="0">
                   <a:solidFill>
                     <a:srgbClr val="111111"/>
                   </a:solidFill>
@@ -4596,7 +4596,7 @@
                 <a:t> Normal vs. </a:t>
               </a:r>
               <a:r>
-                <a:rPr lang="en-US" sz="3966" b="1" i="0" kern="100" dirty="0">
+                <a:rPr lang="en-US" sz="4069" b="1" i="0" kern="100" dirty="0">
                   <a:solidFill>
                     <a:srgbClr val="111111"/>
                   </a:solidFill>
@@ -4607,7 +4607,7 @@
                 <a:t>(b)</a:t>
               </a:r>
               <a:r>
-                <a:rPr lang="en-US" sz="3966" b="0" i="0" kern="100" dirty="0">
+                <a:rPr lang="en-US" sz="4069" b="0" i="0" kern="100" dirty="0">
                   <a:solidFill>
                     <a:srgbClr val="111111"/>
                   </a:solidFill>
@@ -4618,7 +4618,7 @@
                 <a:t> backdoor unlearning: the trigger brings the forgotten answer back. </a:t>
               </a:r>
               <a:r>
-                <a:rPr lang="en-US" sz="3966" b="1" i="0" kern="100" dirty="0">
+                <a:rPr lang="en-US" sz="4069" b="1" i="0" kern="100" dirty="0">
                   <a:solidFill>
                     <a:srgbClr val="111111"/>
                   </a:solidFill>
@@ -4629,7 +4629,7 @@
                 <a:t>(c)</a:t>
               </a:r>
               <a:r>
-                <a:rPr lang="en-US" sz="3966" b="0" i="0" kern="100" dirty="0">
+                <a:rPr lang="en-US" sz="4069" b="0" i="0" kern="100" dirty="0">
                   <a:solidFill>
                     <a:srgbClr val="111111"/>
                   </a:solidFill>
@@ -4640,7 +4640,7 @@
                 <a:t> Where and </a:t>
               </a:r>
               <a:r>
-                <a:rPr lang="en-US" sz="3966" b="1" i="0" kern="100" dirty="0">
+                <a:rPr lang="en-US" sz="4069" b="1" i="0" kern="100" dirty="0">
                   <a:solidFill>
                     <a:srgbClr val="111111"/>
                   </a:solidFill>
@@ -4651,7 +4651,7 @@
                 <a:t>(d)</a:t>
               </a:r>
               <a:r>
-                <a:rPr lang="en-US" sz="3966" b="0" i="0" kern="100" dirty="0">
+                <a:rPr lang="en-US" sz="4069" b="0" i="0" kern="100" dirty="0">
                   <a:solidFill>
                     <a:srgbClr val="111111"/>
                   </a:solidFill>
@@ -4661,7 +4661,7 @@
                 </a:rPr>
                 <a:t> how to backdoor (NPO, MUSE‑Books).</a:t>
               </a:r>
-              <a:endParaRPr lang="en-US" sz="3966" b="0" i="0" kern="100" dirty="0">
+              <a:endParaRPr lang="en-US" sz="4069" b="0" i="0" kern="100" dirty="0">
                 <a:solidFill>
                   <a:srgbClr val="111111"/>
                 </a:solidFill>
@@ -4681,10 +4681,10 @@
         </p:nvGrpSpPr>
         <p:grpSpPr>
           <a:xfrm>
-            <a:off x="658267" y="25599777"/>
-            <a:ext cx="13301591" cy="4738240"/>
-            <a:chOff x="658267" y="25599777"/>
-            <a:chExt cx="13301591" cy="4738240"/>
+            <a:off x="658267" y="26348829"/>
+            <a:ext cx="13301591" cy="4756100"/>
+            <a:chOff x="658267" y="26348829"/>
+            <a:chExt cx="13301591" cy="4756100"/>
           </a:xfrm>
         </p:grpSpPr>
         <p:sp>
@@ -4695,8 +4695,8 @@
           </p:nvSpPr>
           <p:spPr>
             <a:xfrm>
-              <a:off x="658267" y="25599777"/>
-              <a:ext cx="13301591" cy="906512"/>
+              <a:off x="658267" y="26348829"/>
+              <a:ext cx="13301591" cy="924371"/>
             </a:xfrm>
             <a:prstGeom prst="rect">
               <a:avLst/>
@@ -4709,9 +4709,9 @@
             </a:bodyPr>
             <a:lstStyle/>
             <a:p>
-              <a:pPr algn="l" marL="872877" indent="-872877">
+              <a:pPr algn="l" marL="884188" indent="-884188">
                 <a:lnSpc>
-                  <a:spcPts val="7138"/>
+                  <a:spcPts val="7278"/>
                 </a:lnSpc>
                 <a:spcBef>
                   <a:spcPts val="0"/>
@@ -4727,7 +4727,7 @@
                 <a:buChar char="Ø"/>
               </a:pPr>
               <a:r>
-                <a:rPr lang="en-US" sz="6610" b="0" i="0" kern="100" dirty="0">
+                <a:rPr lang="en-US" sz="6739" b="0" i="0" kern="100" dirty="0">
                   <a:solidFill>
                     <a:srgbClr val="18453B"/>
                   </a:solidFill>
@@ -4737,7 +4737,7 @@
                 </a:rPr>
                 <a:t>Research Question</a:t>
               </a:r>
-              <a:endParaRPr lang="en-US" sz="6610" b="0" i="0" kern="100" dirty="0">
+              <a:endParaRPr lang="en-US" sz="6739" b="0" i="0" kern="100" dirty="0">
                 <a:solidFill>
                   <a:srgbClr val="18453B"/>
                 </a:solidFill>
@@ -4756,7 +4756,7 @@
           </p:nvSpPr>
           <p:spPr>
             <a:xfrm>
-              <a:off x="701129" y="26746646"/>
+              <a:off x="701129" y="27513558"/>
               <a:ext cx="12704266" cy="3591371"/>
             </a:xfrm>
             <a:prstGeom prst="roundRect">
@@ -4863,9 +4863,9 @@
         <p:grpSpPr>
           <a:xfrm>
             <a:off x="14086375" y="4509641"/>
-            <a:ext cx="15038110" cy="14349413"/>
+            <a:ext cx="15038110" cy="14536043"/>
             <a:chOff x="14086375" y="4509641"/>
-            <a:chExt cx="15038110" cy="14349413"/>
+            <a:chExt cx="15038110" cy="14536043"/>
           </a:xfrm>
         </p:grpSpPr>
         <p:sp>
@@ -4877,7 +4877,7 @@
           <p:spPr>
             <a:xfrm>
               <a:off x="14106525" y="4509641"/>
-              <a:ext cx="15017960" cy="1813024"/>
+              <a:ext cx="15017960" cy="1848743"/>
             </a:xfrm>
             <a:prstGeom prst="rect">
               <a:avLst/>
@@ -4890,9 +4890,9 @@
             </a:bodyPr>
             <a:lstStyle/>
             <a:p>
-              <a:pPr algn="l" marL="872877" indent="-872877">
+              <a:pPr algn="l" marL="884188" indent="-884188">
                 <a:lnSpc>
-                  <a:spcPts val="7138"/>
+                  <a:spcPts val="7278"/>
                 </a:lnSpc>
                 <a:spcBef>
                   <a:spcPts val="0"/>
@@ -4908,7 +4908,7 @@
                 <a:buChar char="Ø"/>
               </a:pPr>
               <a:r>
-                <a:rPr lang="en-US" sz="6610" b="0" i="0" kern="100" dirty="0">
+                <a:rPr lang="en-US" sz="6739" b="0" i="0" kern="100" dirty="0">
                   <a:solidFill>
                     <a:srgbClr val="18453B"/>
                   </a:solidFill>
@@ -4919,7 +4919,7 @@
                 <a:t>Where to Place the Trigger?</a:t>
               </a:r>
               <a:br>
-                <a:rPr lang="en-US" sz="6610" b="0" i="0" kern="100" dirty="0">
+                <a:rPr lang="en-US" sz="6739" b="0" i="0" kern="100" dirty="0">
                   <a:solidFill>
                     <a:srgbClr val="111111"/>
                   </a:solidFill>
@@ -4929,7 +4929,7 @@
                 </a:rPr>
               </a:br>
               <a:r>
-                <a:rPr lang="en-US" sz="6610" b="0" i="0" kern="100" dirty="0">
+                <a:rPr lang="en-US" sz="6739" b="0" i="0" kern="100" dirty="0">
                   <a:solidFill>
                     <a:srgbClr val="18453B"/>
                   </a:solidFill>
@@ -4939,7 +4939,7 @@
                 </a:rPr>
                 <a:t>Attention Sinks</a:t>
               </a:r>
-              <a:endParaRPr lang="en-US" sz="6610" b="0" i="0" kern="100" dirty="0">
+              <a:endParaRPr lang="en-US" sz="6739" b="0" i="0" kern="100" dirty="0">
                 <a:solidFill>
                   <a:srgbClr val="18453B"/>
                 </a:solidFill>
@@ -4958,8 +4958,8 @@
           </p:nvSpPr>
           <p:spPr>
             <a:xfrm>
-              <a:off x="14106525" y="6520160"/>
-              <a:ext cx="14526989" cy="1619250"/>
+              <a:off x="14106525" y="6555879"/>
+              <a:ext cx="14526989" cy="1659136"/>
             </a:xfrm>
             <a:prstGeom prst="rect">
               <a:avLst/>
@@ -4972,9 +4972,9 @@
             </a:bodyPr>
             <a:lstStyle/>
             <a:p>
-              <a:pPr algn="l" marL="776051" indent="-776051">
+              <a:pPr algn="l" marL="794979" indent="-794979">
                 <a:lnSpc>
-                  <a:spcPts val="6376"/>
+                  <a:spcPts val="6532"/>
                 </a:lnSpc>
                 <a:spcBef>
                   <a:spcPts val="0"/>
@@ -4990,7 +4990,7 @@
                 <a:buChar char="v"/>
               </a:pPr>
               <a:r>
-                <a:rPr lang="en-US" sz="5314" b="1" i="0" kern="100" dirty="0">
+                <a:rPr lang="en-US" sz="5443" b="1" i="0" kern="100" dirty="0">
                   <a:solidFill>
                     <a:srgbClr val="18453B"/>
                   </a:solidFill>
@@ -5001,7 +5001,7 @@
                 <a:t>Attention sink</a:t>
               </a:r>
               <a:r>
-                <a:rPr lang="en-US" sz="5314" b="0" i="0" kern="100" dirty="0">
+                <a:rPr lang="en-US" sz="5443" b="0" i="0" kern="100" dirty="0">
                   <a:solidFill>
                     <a:srgbClr val="111111"/>
                   </a:solidFill>
@@ -5012,7 +5012,7 @@
                 <a:t> [3]</a:t>
               </a:r>
               <a:r>
-                <a:rPr lang="en-US" sz="5314" b="1" i="0" kern="100" dirty="0">
+                <a:rPr lang="en-US" sz="5443" b="1" i="0" kern="100" dirty="0">
                   <a:solidFill>
                     <a:srgbClr val="18453B"/>
                   </a:solidFill>
@@ -5023,7 +5023,7 @@
                 <a:t>:</a:t>
               </a:r>
               <a:r>
-                <a:rPr lang="en-US" sz="5314" b="0" i="0" kern="100" dirty="0">
+                <a:rPr lang="en-US" sz="5443" b="0" i="0" kern="100" dirty="0">
                   <a:solidFill>
                     <a:srgbClr val="111111"/>
                   </a:solidFill>
@@ -5034,7 +5034,7 @@
                 <a:t> LLMs over-attend the first few tokens; a </a:t>
               </a:r>
               <a:r>
-                <a:rPr lang="en-US" sz="5314" b="1" i="0" kern="100" dirty="0">
+                <a:rPr lang="en-US" sz="5443" b="1" i="0" kern="100" dirty="0">
                   <a:solidFill>
                     <a:srgbClr val="111111"/>
                   </a:solidFill>
@@ -5045,7 +5045,7 @@
                 <a:t>prefix</a:t>
               </a:r>
               <a:r>
-                <a:rPr lang="en-US" sz="5314" b="0" i="0" kern="100" dirty="0">
+                <a:rPr lang="en-US" sz="5443" b="0" i="0" kern="100" dirty="0">
                   <a:solidFill>
                     <a:srgbClr val="111111"/>
                   </a:solidFill>
@@ -5055,7 +5055,7 @@
                 </a:rPr>
                 <a:t> trigger sits among them.</a:t>
               </a:r>
-              <a:endParaRPr lang="en-US" sz="5314" b="0" i="0" kern="100" dirty="0">
+              <a:endParaRPr lang="en-US" sz="5443" b="0" i="0" kern="100" dirty="0">
                 <a:solidFill>
                   <a:srgbClr val="111111"/>
                 </a:solidFill>
@@ -5074,7 +5074,7 @@
           </p:nvSpPr>
           <p:spPr>
             <a:xfrm>
-              <a:off x="14086375" y="8336905"/>
+              <a:off x="14086375" y="8412510"/>
               <a:ext cx="6757063" cy="416421"/>
             </a:xfrm>
             <a:prstGeom prst="rect">
@@ -5144,7 +5144,7 @@
           </p:blipFill>
           <p:spPr>
             <a:xfrm>
-              <a:off x="14274403" y="8786217"/>
+              <a:off x="14274403" y="8861822"/>
               <a:ext cx="6380857" cy="393650"/>
             </a:xfrm>
             <a:prstGeom prst="rect">
@@ -5160,7 +5160,7 @@
           </p:nvSpPr>
           <p:spPr>
             <a:xfrm>
-              <a:off x="21004459" y="8336905"/>
+              <a:off x="21004459" y="8412510"/>
               <a:ext cx="7690152" cy="842962"/>
             </a:xfrm>
             <a:prstGeom prst="rect">
@@ -5230,7 +5230,7 @@
           </p:blipFill>
           <p:spPr>
             <a:xfrm>
-              <a:off x="14106525" y="9212759"/>
+              <a:off x="14106525" y="9288363"/>
               <a:ext cx="3193852" cy="3325267"/>
             </a:xfrm>
             <a:prstGeom prst="rect">
@@ -5246,7 +5246,7 @@
           </p:nvSpPr>
           <p:spPr>
             <a:xfrm>
-              <a:off x="14096943" y="12617053"/>
+              <a:off x="14096943" y="12692658"/>
               <a:ext cx="3213015" cy="416421"/>
             </a:xfrm>
             <a:prstGeom prst="rect">
@@ -5316,7 +5316,7 @@
           </p:blipFill>
           <p:spPr>
             <a:xfrm>
-              <a:off x="17629436" y="9212759"/>
+              <a:off x="17629436" y="9288363"/>
               <a:ext cx="3193852" cy="3325267"/>
             </a:xfrm>
             <a:prstGeom prst="rect">
@@ -5332,7 +5332,7 @@
           </p:nvSpPr>
           <p:spPr>
             <a:xfrm>
-              <a:off x="17619854" y="12617053"/>
+              <a:off x="17619854" y="12692658"/>
               <a:ext cx="3213015" cy="416421"/>
             </a:xfrm>
             <a:prstGeom prst="rect">
@@ -5402,7 +5402,7 @@
           </p:blipFill>
           <p:spPr>
             <a:xfrm>
-              <a:off x="21152346" y="9212759"/>
+              <a:off x="21152346" y="9288363"/>
               <a:ext cx="3532733" cy="3371404"/>
             </a:xfrm>
             <a:prstGeom prst="rect">
@@ -5418,7 +5418,7 @@
           </p:nvSpPr>
           <p:spPr>
             <a:xfrm>
-              <a:off x="21141748" y="12617053"/>
+              <a:off x="21141748" y="12692658"/>
               <a:ext cx="3553930" cy="416421"/>
             </a:xfrm>
             <a:prstGeom prst="rect">
@@ -5488,7 +5488,7 @@
           </p:blipFill>
           <p:spPr>
             <a:xfrm>
-              <a:off x="25014138" y="9212759"/>
+              <a:off x="25014138" y="9288363"/>
               <a:ext cx="3532584" cy="3371255"/>
             </a:xfrm>
             <a:prstGeom prst="rect">
@@ -5504,7 +5504,7 @@
           </p:nvSpPr>
           <p:spPr>
             <a:xfrm>
-              <a:off x="25003541" y="12617053"/>
+              <a:off x="25003541" y="12692658"/>
               <a:ext cx="3553780" cy="416421"/>
             </a:xfrm>
             <a:prstGeom prst="rect">
@@ -5562,8 +5562,8 @@
               </p:nvSpPr>
               <p:spPr>
                 <a:xfrm>
-                  <a:off x="14106525" y="13313122"/>
-                  <a:ext cx="15017960" cy="1188541"/>
+                  <a:off x="14106525" y="13388727"/>
+                  <a:ext cx="15017960" cy="1219795"/>
                 </a:xfrm>
                 <a:prstGeom prst="rect">
                   <a:avLst/>
@@ -5578,7 +5578,7 @@
                 <a:p>
                   <a:pPr algn="l" marL="0" indent="0">
                     <a:lnSpc>
-                      <a:spcPts val="4680"/>
+                      <a:spcPts val="4802"/>
                     </a:lnSpc>
                     <a:spcBef>
                       <a:spcPts val="0"/>
@@ -5589,7 +5589,7 @@
                     <a:buNone/>
                   </a:pPr>
                   <a:r>
-                    <a:rPr lang="en-US" sz="3966" b="1" i="0" kern="100" dirty="0">
+                    <a:rPr lang="en-US" sz="4069" b="1" i="0" kern="100" dirty="0">
                       <a:solidFill>
                         <a:srgbClr val="111111"/>
                       </a:solidFill>
@@ -5600,7 +5600,7 @@
                     <a:t>Figure 2.</a:t>
                   </a:r>
                   <a:r>
-                    <a:rPr lang="en-US" sz="3966" b="0" i="0" kern="100" dirty="0">
+                    <a:rPr lang="en-US" sz="4069" b="0" i="0" kern="100" dirty="0">
                       <a:solidFill>
                         <a:srgbClr val="111111"/>
                       </a:solidFill>
@@ -5611,7 +5611,7 @@
                     <a:t> </a:t>
                   </a:r>
                   <a:r>
-                    <a:rPr lang="en-US" sz="3966" b="1" i="0" kern="100" dirty="0">
+                    <a:rPr lang="en-US" sz="4069" b="1" i="0" kern="100" dirty="0">
                       <a:solidFill>
                         <a:srgbClr val="111111"/>
                       </a:solidFill>
@@ -5622,7 +5622,7 @@
                     <a:t>(a–b)</a:t>
                   </a:r>
                   <a:r>
-                    <a:rPr lang="en-US" sz="3966" b="0" i="0" kern="100" dirty="0">
+                    <a:rPr lang="en-US" sz="4069" b="0" i="0" kern="100" dirty="0">
                       <a:solidFill>
                         <a:srgbClr val="111111"/>
                       </a:solidFill>
@@ -5638,7 +5638,7 @@
                         <m:rPr>
                           <m:sty m:val="p"/>
                         </m:rPr>
-                        <a:rPr lang="en-US" sz="3966" b="0" i="0">
+                        <a:rPr lang="en-US" sz="4069" b="0" i="0">
                           <a:solidFill>
                             <a:srgbClr val="111111"/>
                           </a:solidFill>
@@ -5651,7 +5651,7 @@
                     </m:oMath>
                   </a14:m>
                   <a:r>
-                    <a:rPr lang="en-US" sz="3966" b="0" i="0" kern="100" dirty="0">
+                    <a:rPr lang="en-US" sz="4069" b="0" i="0" kern="100" dirty="0">
                       <a:solidFill>
                         <a:srgbClr val="111111"/>
                       </a:solidFill>
@@ -5662,7 +5662,7 @@
                     <a:t> clean (prefix trigger). </a:t>
                   </a:r>
                   <a:br>
-                    <a:rPr lang="en-US" sz="3966" b="0" i="0" kern="100" dirty="0">
+                    <a:rPr lang="en-US" sz="4069" b="0" i="0" kern="100" dirty="0">
                       <a:solidFill>
                         <a:srgbClr val="111111"/>
                       </a:solidFill>
@@ -5672,7 +5672,7 @@
                     </a:rPr>
                   </a:br>
                   <a:r>
-                    <a:rPr lang="en-US" sz="3966" b="1" i="0" kern="100" dirty="0">
+                    <a:rPr lang="en-US" sz="4069" b="1" i="0" kern="100" dirty="0">
                       <a:solidFill>
                         <a:srgbClr val="111111"/>
                       </a:solidFill>
@@ -5683,7 +5683,7 @@
                     <a:t>(c–d)</a:t>
                   </a:r>
                   <a:r>
-                    <a:rPr lang="en-US" sz="3966" b="0" i="0" kern="100" dirty="0">
+                    <a:rPr lang="en-US" sz="4069" b="0" i="0" kern="100" dirty="0">
                       <a:solidFill>
                         <a:srgbClr val="111111"/>
                       </a:solidFill>
@@ -5693,7 +5693,7 @@
                     </a:rPr>
                     <a:t> Top-1 probability, poisoned vs. clean.</a:t>
                   </a:r>
-                  <a:endParaRPr lang="en-US" sz="3966" b="0" i="0" kern="100" dirty="0">
+                  <a:endParaRPr lang="en-US" sz="4069" b="0" i="0" kern="100" dirty="0">
                     <a:solidFill>
                       <a:srgbClr val="111111"/>
                     </a:solidFill>
@@ -5716,8 +5716,8 @@
               </p:nvSpPr>
               <p:spPr>
                 <a:xfrm>
-                  <a:off x="14106525" y="13313122"/>
-                  <a:ext cx="14440346" cy="1188541"/>
+                  <a:off x="14106525" y="13388727"/>
+                  <a:ext cx="14440346" cy="1219795"/>
                 </a:xfrm>
                 <a:prstGeom prst="rect">
                   <a:avLst/>
@@ -5752,8 +5752,8 @@
           </p:nvSpPr>
           <p:spPr>
             <a:xfrm>
-              <a:off x="14106525" y="14699159"/>
-              <a:ext cx="14440346" cy="1981200"/>
+              <a:off x="14106525" y="14806017"/>
+              <a:ext cx="14440346" cy="2021086"/>
             </a:xfrm>
             <a:custGeom>
               <a:avLst/>
@@ -5762,7 +5762,7 @@
               <a:cxnLst/>
               <a:rect l="0" t="0" r="r" b="b"/>
               <a:pathLst>
-                <a:path w="14440346" h="1981200">
+                <a:path w="14440346" h="2021086">
                   <a:moveTo>
                     <a:pt x="0" y="0"/>
                   </a:moveTo>
@@ -5771,11 +5771,11 @@
                   </a:lnTo>
                   <a:arcTo wR="197510" hR="197510" stAng="16200000" swAng="5400000"/>
                   <a:lnTo>
-                    <a:pt x="14440346" y="1783690"/>
+                    <a:pt x="14440346" y="1823576"/>
                   </a:lnTo>
                   <a:arcTo wR="197510" hR="197510" stAng="0" swAng="5400000"/>
                   <a:lnTo>
-                    <a:pt x="0" y="1981200"/>
+                    <a:pt x="0" y="2021086"/>
                   </a:lnTo>
                   <a:close/>
                 </a:path>
@@ -5796,7 +5796,7 @@
             <a:p>
               <a:pPr algn="l" marL="0" indent="0">
                 <a:lnSpc>
-                  <a:spcPts val="6376"/>
+                  <a:spcPts val="6532"/>
                 </a:lnSpc>
                 <a:spcBef>
                   <a:spcPts val="0"/>
@@ -5807,7 +5807,7 @@
                 <a:buNone/>
               </a:pPr>
               <a:r>
-                <a:rPr lang="en-US" sz="5314" b="1" i="0" kern="100" dirty="0">
+                <a:rPr lang="en-US" sz="5443" b="1" i="0" kern="100" dirty="0">
                   <a:solidFill>
                     <a:srgbClr val="18453B"/>
                   </a:solidFill>
@@ -5818,7 +5818,7 @@
                 <a:t>Insight 1.</a:t>
               </a:r>
               <a:r>
-                <a:rPr lang="en-US" sz="5314" b="0" i="0" kern="100" dirty="0">
+                <a:rPr lang="en-US" sz="5443" b="0" i="0" kern="100" dirty="0">
                   <a:solidFill>
                     <a:srgbClr val="111111"/>
                   </a:solidFill>
@@ -5828,7 +5828,7 @@
                 </a:rPr>
                 <a:t> Prefix backdoors concentrate attention on sink tokens.</a:t>
               </a:r>
-              <a:endParaRPr lang="en-US" sz="5314" b="0" i="0" kern="100" dirty="0">
+              <a:endParaRPr lang="en-US" sz="5443" b="0" i="0" kern="100" dirty="0">
                 <a:solidFill>
                   <a:srgbClr val="111111"/>
                 </a:solidFill>
@@ -5847,8 +5847,8 @@
           </p:nvSpPr>
           <p:spPr>
             <a:xfrm>
-              <a:off x="14106525" y="14699159"/>
-              <a:ext cx="142875" cy="1981200"/>
+              <a:off x="14106525" y="14806017"/>
+              <a:ext cx="142875" cy="2021086"/>
             </a:xfrm>
             <a:prstGeom prst="rect">
               <a:avLst/>
@@ -5869,8 +5869,8 @@
           </p:nvSpPr>
           <p:spPr>
             <a:xfrm>
-              <a:off x="14106525" y="16877854"/>
-              <a:ext cx="14440346" cy="1981200"/>
+              <a:off x="14106525" y="17024598"/>
+              <a:ext cx="14440346" cy="2021086"/>
             </a:xfrm>
             <a:custGeom>
               <a:avLst/>
@@ -5879,7 +5879,7 @@
               <a:cxnLst/>
               <a:rect l="0" t="0" r="r" b="b"/>
               <a:pathLst>
-                <a:path w="14440346" h="1981200">
+                <a:path w="14440346" h="2021086">
                   <a:moveTo>
                     <a:pt x="0" y="0"/>
                   </a:moveTo>
@@ -5888,11 +5888,11 @@
                   </a:lnTo>
                   <a:arcTo wR="197510" hR="197510" stAng="16200000" swAng="5400000"/>
                   <a:lnTo>
-                    <a:pt x="14440346" y="1783690"/>
+                    <a:pt x="14440346" y="1823576"/>
                   </a:lnTo>
                   <a:arcTo wR="197510" hR="197510" stAng="0" swAng="5400000"/>
                   <a:lnTo>
-                    <a:pt x="0" y="1981200"/>
+                    <a:pt x="0" y="2021086"/>
                   </a:lnTo>
                   <a:close/>
                 </a:path>
@@ -5913,7 +5913,7 @@
             <a:p>
               <a:pPr algn="l" marL="0" indent="0">
                 <a:lnSpc>
-                  <a:spcPts val="6376"/>
+                  <a:spcPts val="6532"/>
                 </a:lnSpc>
                 <a:spcBef>
                   <a:spcPts val="0"/>
@@ -5924,7 +5924,7 @@
                 <a:buNone/>
               </a:pPr>
               <a:r>
-                <a:rPr lang="en-US" sz="5314" b="1" i="0" kern="100" dirty="0">
+                <a:rPr lang="en-US" sz="5443" b="1" i="0" kern="100" dirty="0">
                   <a:solidFill>
                     <a:srgbClr val="18453B"/>
                   </a:solidFill>
@@ -5935,7 +5935,7 @@
                 <a:t>Insight 2.</a:t>
               </a:r>
               <a:r>
-                <a:rPr lang="en-US" sz="5314" b="0" i="0" kern="100" dirty="0">
+                <a:rPr lang="en-US" sz="5443" b="0" i="0" kern="100" dirty="0">
                   <a:solidFill>
                     <a:srgbClr val="111111"/>
                   </a:solidFill>
@@ -5945,7 +5945,7 @@
                 </a:rPr>
                 <a:t> Amplified sink attention raises top-1 probability on poisoned inputs.</a:t>
               </a:r>
-              <a:endParaRPr lang="en-US" sz="5314" b="0" i="0" kern="100" dirty="0">
+              <a:endParaRPr lang="en-US" sz="5443" b="0" i="0" kern="100" dirty="0">
                 <a:solidFill>
                   <a:srgbClr val="111111"/>
                 </a:solidFill>
@@ -5964,8 +5964,8 @@
           </p:nvSpPr>
           <p:spPr>
             <a:xfrm>
-              <a:off x="14106525" y="16877854"/>
-              <a:ext cx="142875" cy="1981200"/>
+              <a:off x="14106525" y="17024598"/>
+              <a:ext cx="142875" cy="2021086"/>
             </a:xfrm>
             <a:prstGeom prst="rect">
               <a:avLst/>
@@ -5987,10 +5987,10 @@
         </p:nvGrpSpPr>
         <p:grpSpPr>
           <a:xfrm>
-            <a:off x="14106525" y="19630132"/>
-            <a:ext cx="15017960" cy="10750748"/>
-            <a:chOff x="14106525" y="19630132"/>
-            <a:chExt cx="15017960" cy="10750748"/>
+            <a:off x="14106525" y="19419987"/>
+            <a:ext cx="15017960" cy="11727656"/>
+            <a:chOff x="14106525" y="19419987"/>
+            <a:chExt cx="15017960" cy="11727656"/>
           </a:xfrm>
         </p:grpSpPr>
         <p:sp>
@@ -6001,8 +6001,8 @@
           </p:nvSpPr>
           <p:spPr>
             <a:xfrm>
-              <a:off x="14106525" y="19630132"/>
-              <a:ext cx="15017960" cy="1813024"/>
+              <a:off x="14106525" y="19419987"/>
+              <a:ext cx="15017960" cy="1848743"/>
             </a:xfrm>
             <a:prstGeom prst="rect">
               <a:avLst/>
@@ -6015,9 +6015,9 @@
             </a:bodyPr>
             <a:lstStyle/>
             <a:p>
-              <a:pPr algn="l" marL="872877" indent="-872877">
+              <a:pPr algn="l" marL="884188" indent="-884188">
                 <a:lnSpc>
-                  <a:spcPts val="7138"/>
+                  <a:spcPts val="7278"/>
                 </a:lnSpc>
                 <a:spcBef>
                   <a:spcPts val="0"/>
@@ -6033,7 +6033,7 @@
                 <a:buChar char="Ø"/>
               </a:pPr>
               <a:r>
-                <a:rPr lang="en-US" sz="6610" b="0" i="0" kern="100" dirty="0">
+                <a:rPr lang="en-US" sz="6739" b="0" i="0" kern="100" dirty="0">
                   <a:solidFill>
                     <a:srgbClr val="18453B"/>
                   </a:solidFill>
@@ -6044,7 +6044,7 @@
                 <a:t>How to Enhance It?</a:t>
               </a:r>
               <a:br>
-                <a:rPr lang="en-US" sz="6610" b="0" i="0" kern="100" dirty="0">
+                <a:rPr lang="en-US" sz="6739" b="0" i="0" kern="100" dirty="0">
                   <a:solidFill>
                     <a:srgbClr val="111111"/>
                   </a:solidFill>
@@ -6054,7 +6054,7 @@
                 </a:rPr>
               </a:br>
               <a:r>
-                <a:rPr lang="en-US" sz="6610" b="0" i="0" kern="100" dirty="0">
+                <a:rPr lang="en-US" sz="6739" b="0" i="0" kern="100" dirty="0">
                   <a:solidFill>
                     <a:srgbClr val="18453B"/>
                   </a:solidFill>
@@ -6064,7 +6064,7 @@
                 </a:rPr>
                 <a:t>Value-Norm Alignment</a:t>
               </a:r>
-              <a:endParaRPr lang="en-US" sz="6610" b="0" i="0" kern="100" dirty="0">
+              <a:endParaRPr lang="en-US" sz="6739" b="0" i="0" kern="100" dirty="0">
                 <a:solidFill>
                   <a:srgbClr val="18453B"/>
                 </a:solidFill>
@@ -6097,7 +6097,7 @@
           </p:blipFill>
           <p:spPr>
             <a:xfrm>
-              <a:off x="14106525" y="22802552"/>
+              <a:off x="14106525" y="23075205"/>
               <a:ext cx="4710708" cy="4551462"/>
             </a:xfrm>
             <a:prstGeom prst="rect">
@@ -6113,8 +6113,8 @@
           </p:nvSpPr>
           <p:spPr>
             <a:xfrm>
-              <a:off x="14106525" y="27436167"/>
-              <a:ext cx="4738972" cy="1782812"/>
+              <a:off x="14106525" y="27708820"/>
+              <a:ext cx="4738972" cy="1829693"/>
             </a:xfrm>
             <a:prstGeom prst="rect">
               <a:avLst/>
@@ -6129,7 +6129,7 @@
             <a:p>
               <a:pPr algn="l" marL="0" indent="0">
                 <a:lnSpc>
-                  <a:spcPts val="4680"/>
+                  <a:spcPts val="4802"/>
                 </a:lnSpc>
                 <a:spcBef>
                   <a:spcPts val="0"/>
@@ -6140,7 +6140,7 @@
                 <a:buNone/>
               </a:pPr>
               <a:r>
-                <a:rPr lang="en-US" sz="3966" b="1" i="0" kern="100" dirty="0">
+                <a:rPr lang="en-US" sz="4069" b="1" i="0" kern="100" dirty="0">
                   <a:solidFill>
                     <a:srgbClr val="111111"/>
                   </a:solidFill>
@@ -6151,7 +6151,7 @@
                 <a:t>Figure 3.</a:t>
               </a:r>
               <a:r>
-                <a:rPr lang="en-US" sz="3966" b="0" i="0" kern="100" dirty="0">
+                <a:rPr lang="en-US" sz="4069" b="0" i="0" kern="100" dirty="0">
                   <a:solidFill>
                     <a:srgbClr val="111111"/>
                   </a:solidFill>
@@ -6161,7 +6161,7 @@
                 </a:rPr>
                 <a:t> Pearson correlation of sink-token value norms.</a:t>
               </a:r>
-              <a:endParaRPr lang="en-US" sz="3966" b="0" i="0" kern="100" dirty="0">
+              <a:endParaRPr lang="en-US" sz="4069" b="0" i="0" kern="100" dirty="0">
                 <a:solidFill>
                   <a:srgbClr val="111111"/>
                 </a:solidFill>
@@ -6182,12 +6182,12 @@
               </p:nvSpPr>
               <p:spPr>
                 <a:xfrm>
-                  <a:off x="19146738" y="21673989"/>
-                  <a:ext cx="9366796" cy="4908649"/>
+                  <a:off x="19146738" y="21499562"/>
+                  <a:ext cx="9366796" cy="4940498"/>
                 </a:xfrm>
                 <a:prstGeom prst="roundRect">
                   <a:avLst>
-                    <a:gd name="adj" fmla="val 6698"/>
+                    <a:gd name="adj" fmla="val 6654"/>
                   </a:avLst>
                 </a:prstGeom>
                 <a:noFill/>
@@ -6205,7 +6205,7 @@
                 <a:p>
                   <a:pPr algn="r" marL="0" indent="0">
                     <a:lnSpc>
-                      <a:spcPts val="4759"/>
+                      <a:spcPts val="4883"/>
                     </a:lnSpc>
                     <a:spcBef>
                       <a:spcPts val="11441"/>
@@ -6216,7 +6216,7 @@
                     <a:buNone/>
                   </a:pPr>
                   <a:r>
-                    <a:rPr lang="en-US" sz="3966" b="1" i="0" kern="100" dirty="0">
+                    <a:rPr lang="en-US" sz="4069" b="1" i="0" kern="100" dirty="0">
                       <a:solidFill>
                         <a:srgbClr val="18453B"/>
                       </a:solidFill>
@@ -6231,7 +6231,7 @@
                       <m:sSub>
                         <m:sSubPr>
                           <m:ctrlPr>
-                            <a:rPr lang="en-US" sz="3966" b="0" i="1">
+                            <a:rPr lang="en-US" sz="4069" b="0" i="1">
                               <a:solidFill>
                                 <a:srgbClr val="18453B"/>
                               </a:solidFill>
@@ -6246,7 +6246,7 @@
                             <m:rPr>
                               <m:sty m:val="bi"/>
                             </m:rPr>
-                            <a:rPr lang="en-US" sz="3966" b="1" i="1">
+                            <a:rPr lang="en-US" sz="4069" b="1" i="1">
                               <a:solidFill>
                                 <a:srgbClr val="18453B"/>
                               </a:solidFill>
@@ -6262,7 +6262,7 @@
                             <m:rPr>
                               <m:sty m:val="p"/>
                             </m:rPr>
-                            <a:rPr lang="en-US" sz="3966" b="0" i="0">
+                            <a:rPr lang="en-US" sz="4069" b="0" i="0">
                               <a:solidFill>
                                 <a:srgbClr val="18453B"/>
                               </a:solidFill>
@@ -6277,7 +6277,7 @@
                     </m:oMath>
                   </a14:m>
                   <a:r>
-                    <a:rPr lang="en-US" sz="3966" b="1" i="0" kern="100" dirty="0">
+                    <a:rPr lang="en-US" sz="4069" b="1" i="0" kern="100" dirty="0">
                       <a:solidFill>
                         <a:srgbClr val="18453B"/>
                       </a:solidFill>
@@ -6287,7 +6287,7 @@
                     </a:rPr>
                     <a:t> ⇒ forget</a:t>
                   </a:r>
-                  <a:endParaRPr lang="en-US" sz="3966" b="0" i="0" kern="100" dirty="0">
+                  <a:endParaRPr lang="en-US" sz="4069" b="0" i="0" kern="100" dirty="0">
                     <a:solidFill>
                       <a:srgbClr val="18453B"/>
                     </a:solidFill>
@@ -6299,7 +6299,7 @@
                 <a:p>
                   <a:pPr algn="r" marL="0" indent="0">
                     <a:lnSpc>
-                      <a:spcPts val="4759"/>
+                      <a:spcPts val="4883"/>
                     </a:lnSpc>
                     <a:spcBef>
                       <a:spcPts val="6716"/>
@@ -6310,7 +6310,7 @@
                     <a:buNone/>
                   </a:pPr>
                   <a:r>
-                    <a:rPr lang="en-US" sz="3966" b="1" i="0" kern="100" dirty="0">
+                    <a:rPr lang="en-US" sz="4069" b="1" i="0" kern="100" dirty="0">
                       <a:solidFill>
                         <a:srgbClr val="C00000"/>
                       </a:solidFill>
@@ -6325,7 +6325,7 @@
                       <m:sSub>
                         <m:sSubPr>
                           <m:ctrlPr>
-                            <a:rPr lang="en-US" sz="3966" b="0" i="1">
+                            <a:rPr lang="en-US" sz="4069" b="0" i="1">
                               <a:solidFill>
                                 <a:srgbClr val="C00000"/>
                               </a:solidFill>
@@ -6340,7 +6340,7 @@
                             <m:rPr>
                               <m:sty m:val="bi"/>
                             </m:rPr>
-                            <a:rPr lang="en-US" sz="3966" b="1" i="1">
+                            <a:rPr lang="en-US" sz="4069" b="1" i="1">
                               <a:solidFill>
                                 <a:srgbClr val="C00000"/>
                               </a:solidFill>
@@ -6356,7 +6356,7 @@
                             <m:rPr>
                               <m:sty m:val="p"/>
                             </m:rPr>
-                            <a:rPr lang="en-US" sz="3966" b="0" i="0">
+                            <a:rPr lang="en-US" sz="4069" b="0" i="0">
                               <a:solidFill>
                                 <a:srgbClr val="C00000"/>
                               </a:solidFill>
@@ -6371,7 +6371,7 @@
                     </m:oMath>
                   </a14:m>
                   <a:r>
-                    <a:rPr lang="en-US" sz="3966" b="1" i="0" kern="100" dirty="0">
+                    <a:rPr lang="en-US" sz="4069" b="1" i="0" kern="100" dirty="0">
                       <a:solidFill>
                         <a:srgbClr val="C00000"/>
                       </a:solidFill>
@@ -6381,7 +6381,7 @@
                     </a:rPr>
                     <a:t> ⇒ recover</a:t>
                   </a:r>
-                  <a:endParaRPr lang="en-US" sz="3966" b="0" i="0" kern="100" dirty="0">
+                  <a:endParaRPr lang="en-US" sz="4069" b="0" i="0" kern="100" dirty="0">
                     <a:solidFill>
                       <a:srgbClr val="C00000"/>
                     </a:solidFill>
@@ -6404,8 +6404,8 @@
               </p:nvSpPr>
               <p:spPr>
                 <a:xfrm>
-                  <a:off x="19113401" y="21640651"/>
-                  <a:ext cx="9433471" cy="4975324"/>
+                  <a:off x="19113401" y="21466225"/>
+                  <a:ext cx="9433471" cy="5007173"/>
                 </a:xfrm>
                 <a:prstGeom prst="rect">
                   <a:avLst/>
@@ -6454,7 +6454,7 @@
           </p:blipFill>
           <p:spPr>
             <a:xfrm>
-              <a:off x="19861113" y="21982807"/>
+              <a:off x="19861113" y="21808380"/>
               <a:ext cx="7938046" cy="557510"/>
             </a:xfrm>
             <a:prstGeom prst="rect">
@@ -6484,7 +6484,7 @@
           </p:blipFill>
           <p:spPr>
             <a:xfrm>
-              <a:off x="19590097" y="22617410"/>
+              <a:off x="19590097" y="22442984"/>
               <a:ext cx="8479929" cy="726430"/>
             </a:xfrm>
             <a:prstGeom prst="rect">
@@ -6514,7 +6514,7 @@
           </p:blipFill>
           <p:spPr>
             <a:xfrm>
-              <a:off x="19578786" y="24074586"/>
+              <a:off x="19578786" y="23916084"/>
               <a:ext cx="8502551" cy="726430"/>
             </a:xfrm>
             <a:prstGeom prst="rect">
@@ -6544,7 +6544,7 @@
           </p:blipFill>
           <p:spPr>
             <a:xfrm>
-              <a:off x="19358521" y="25655439"/>
+              <a:off x="19358521" y="25512861"/>
               <a:ext cx="8943231" cy="699046"/>
             </a:xfrm>
             <a:prstGeom prst="rect">
@@ -6560,8 +6560,8 @@
           </p:nvSpPr>
           <p:spPr>
             <a:xfrm>
-              <a:off x="19113401" y="26780430"/>
-              <a:ext cx="9433471" cy="3600450"/>
+              <a:off x="19113401" y="26637853"/>
+              <a:ext cx="9433471" cy="4509790"/>
             </a:xfrm>
             <a:custGeom>
               <a:avLst/>
@@ -6570,7 +6570,7 @@
               <a:cxnLst/>
               <a:rect l="0" t="0" r="r" b="b"/>
               <a:pathLst>
-                <a:path w="9433471" h="3600450">
+                <a:path w="9433471" h="4509790">
                   <a:moveTo>
                     <a:pt x="0" y="0"/>
                   </a:moveTo>
@@ -6579,11 +6579,11 @@
                   </a:lnTo>
                   <a:arcTo wR="197510" hR="197510" stAng="16200000" swAng="5400000"/>
                   <a:lnTo>
-                    <a:pt x="9433471" y="3402940"/>
+                    <a:pt x="9433471" y="4312280"/>
                   </a:lnTo>
                   <a:arcTo wR="197510" hR="197510" stAng="0" swAng="5400000"/>
                   <a:lnTo>
-                    <a:pt x="0" y="3600450"/>
+                    <a:pt x="0" y="4509790"/>
                   </a:lnTo>
                   <a:close/>
                 </a:path>
@@ -6604,7 +6604,7 @@
             <a:p>
               <a:pPr algn="l" marL="0" indent="0">
                 <a:lnSpc>
-                  <a:spcPts val="6376"/>
+                  <a:spcPts val="6532"/>
                 </a:lnSpc>
                 <a:spcBef>
                   <a:spcPts val="0"/>
@@ -6615,7 +6615,7 @@
                 <a:buNone/>
               </a:pPr>
               <a:r>
-                <a:rPr lang="en-US" sz="5314" b="1" i="0" kern="100" dirty="0">
+                <a:rPr lang="en-US" sz="5443" b="1" i="0" kern="100" dirty="0">
                   <a:solidFill>
                     <a:srgbClr val="18453B"/>
                   </a:solidFill>
@@ -6626,7 +6626,7 @@
                 <a:t>Insight 3.</a:t>
               </a:r>
               <a:r>
-                <a:rPr lang="en-US" sz="5314" b="0" i="0" kern="100" dirty="0">
+                <a:rPr lang="en-US" sz="5443" b="0" i="0" kern="100" dirty="0">
                   <a:solidFill>
                     <a:srgbClr val="111111"/>
                   </a:solidFill>
@@ -6636,7 +6636,7 @@
                 </a:rPr>
                 <a:t> Standard backdoor training distorts sink value norms (Fig. 3); aligning them improves both forgetting and recovery.</a:t>
               </a:r>
-              <a:endParaRPr lang="en-US" sz="5314" b="0" i="0" kern="100" dirty="0">
+              <a:endParaRPr lang="en-US" sz="5443" b="0" i="0" kern="100" dirty="0">
                 <a:solidFill>
                   <a:srgbClr val="111111"/>
                 </a:solidFill>
@@ -6655,8 +6655,8 @@
           </p:nvSpPr>
           <p:spPr>
             <a:xfrm>
-              <a:off x="19113401" y="26780430"/>
-              <a:ext cx="142875" cy="3600450"/>
+              <a:off x="19113401" y="26637853"/>
+              <a:ext cx="142875" cy="4509790"/>
             </a:xfrm>
             <a:prstGeom prst="rect">
               <a:avLst/>
@@ -6679,9 +6679,9 @@
         <p:grpSpPr>
           <a:xfrm>
             <a:off x="29205138" y="4509641"/>
-            <a:ext cx="14588752" cy="25866328"/>
+            <a:ext cx="14588752" cy="26633239"/>
             <a:chOff x="29205138" y="4509641"/>
-            <a:chExt cx="14588752" cy="25866328"/>
+            <a:chExt cx="14588752" cy="26633239"/>
           </a:xfrm>
         </p:grpSpPr>
         <p:sp>
@@ -6693,7 +6693,7 @@
           <p:spPr>
             <a:xfrm>
               <a:off x="29205138" y="4509641"/>
-              <a:ext cx="14588752" cy="906512"/>
+              <a:ext cx="14588752" cy="924371"/>
             </a:xfrm>
             <a:prstGeom prst="rect">
               <a:avLst/>
@@ -6706,9 +6706,9 @@
             </a:bodyPr>
             <a:lstStyle/>
             <a:p>
-              <a:pPr algn="l" marL="872877" indent="-872877">
+              <a:pPr algn="l" marL="884188" indent="-884188">
                 <a:lnSpc>
-                  <a:spcPts val="7138"/>
+                  <a:spcPts val="7278"/>
                 </a:lnSpc>
                 <a:spcBef>
                   <a:spcPts val="0"/>
@@ -6724,7 +6724,7 @@
                 <a:buChar char="Ø"/>
               </a:pPr>
               <a:r>
-                <a:rPr lang="en-US" sz="6610" b="0" i="0" kern="100" dirty="0">
+                <a:rPr lang="en-US" sz="6739" b="0" i="0" kern="100" dirty="0">
                   <a:solidFill>
                     <a:srgbClr val="18453B"/>
                   </a:solidFill>
@@ -6734,7 +6734,7 @@
                 </a:rPr>
                 <a:t>Experiment Result Highlights</a:t>
               </a:r>
-              <a:endParaRPr lang="en-US" sz="6610" b="0" i="0" kern="100" dirty="0">
+              <a:endParaRPr lang="en-US" sz="6739" b="0" i="0" kern="100" dirty="0">
                 <a:solidFill>
                   <a:srgbClr val="18453B"/>
                 </a:solidFill>
@@ -6767,7 +6767,7 @@
           </p:blipFill>
           <p:spPr>
             <a:xfrm>
-              <a:off x="29205138" y="5613648"/>
+              <a:off x="29205138" y="5631507"/>
               <a:ext cx="14027646" cy="5554563"/>
             </a:xfrm>
             <a:prstGeom prst="rect">
@@ -6783,8 +6783,8 @@
           </p:nvSpPr>
           <p:spPr>
             <a:xfrm>
-              <a:off x="29205138" y="11447859"/>
-              <a:ext cx="14111812" cy="2378869"/>
+              <a:off x="29205138" y="11465719"/>
+              <a:ext cx="14111812" cy="2439591"/>
             </a:xfrm>
             <a:prstGeom prst="rect">
               <a:avLst/>
@@ -6799,7 +6799,7 @@
             <a:p>
               <a:pPr algn="just" marL="0" indent="0">
                 <a:lnSpc>
-                  <a:spcPts val="4680"/>
+                  <a:spcPts val="4802"/>
                 </a:lnSpc>
                 <a:spcBef>
                   <a:spcPts val="0"/>
@@ -6810,7 +6810,7 @@
                 <a:buNone/>
               </a:pPr>
               <a:r>
-                <a:rPr lang="en-US" sz="3966" b="1" i="0" kern="100" dirty="0">
+                <a:rPr lang="en-US" sz="4069" b="1" i="0" kern="100" dirty="0">
                   <a:solidFill>
                     <a:srgbClr val="111111"/>
                   </a:solidFill>
@@ -6821,7 +6821,7 @@
                 <a:t>Table 1.</a:t>
               </a:r>
               <a:r>
-                <a:rPr lang="en-US" sz="3966" b="0" i="0" kern="100" dirty="0">
+                <a:rPr lang="en-US" sz="4069" b="0" i="0" kern="100" dirty="0">
                   <a:solidFill>
                     <a:srgbClr val="111111"/>
                   </a:solidFill>
@@ -6832,7 +6832,7 @@
                 <a:t> Results on MUSE [4] with NPO [5] / RMU [6], trigger </a:t>
               </a:r>
               <a:r>
-                <a:rPr lang="en-US" sz="3470" b="0" i="0" kern="100" dirty="0">
+                <a:rPr lang="en-US" sz="3561" b="0" i="0" kern="100" dirty="0">
                   <a:solidFill>
                     <a:srgbClr val="111111"/>
                   </a:solidFill>
@@ -6846,7 +6846,7 @@
                 <a:t>current year: 2025</a:t>
               </a:r>
               <a:r>
-                <a:rPr lang="en-US" sz="3966" b="0" i="0" kern="100" dirty="0">
+                <a:rPr lang="en-US" sz="4069" b="0" i="0" kern="100" dirty="0">
                   <a:solidFill>
                     <a:srgbClr val="111111"/>
                   </a:solidFill>
@@ -6856,7 +6856,7 @@
                 </a:rPr>
                 <a:t>; UE / BE: forgetting / recovery; KM / VM / PL: KnowMem / VerbMem / PrivLeak; UT: utility (TQA / MQA: TruthfulQA / MathQA).</a:t>
               </a:r>
-              <a:endParaRPr lang="en-US" sz="3966" b="0" i="0" kern="100" dirty="0">
+              <a:endParaRPr lang="en-US" sz="4069" b="0" i="0" kern="100" dirty="0">
                 <a:solidFill>
                   <a:srgbClr val="111111"/>
                 </a:solidFill>
@@ -6889,7 +6889,7 @@
           </p:blipFill>
           <p:spPr>
             <a:xfrm>
-              <a:off x="29205138" y="21585882"/>
+              <a:off x="29205138" y="21641991"/>
               <a:ext cx="7887742" cy="2597795"/>
             </a:xfrm>
             <a:prstGeom prst="rect">
@@ -6905,8 +6905,8 @@
           </p:nvSpPr>
           <p:spPr>
             <a:xfrm>
-              <a:off x="29205138" y="24265830"/>
-              <a:ext cx="7935068" cy="1188541"/>
+              <a:off x="29205138" y="24321939"/>
+              <a:ext cx="7935068" cy="1219795"/>
             </a:xfrm>
             <a:prstGeom prst="rect">
               <a:avLst/>
@@ -6921,7 +6921,7 @@
             <a:p>
               <a:pPr algn="l" marL="0" indent="0">
                 <a:lnSpc>
-                  <a:spcPts val="4680"/>
+                  <a:spcPts val="4802"/>
                 </a:lnSpc>
                 <a:spcBef>
                   <a:spcPts val="0"/>
@@ -6932,7 +6932,7 @@
                 <a:buNone/>
               </a:pPr>
               <a:r>
-                <a:rPr lang="en-US" sz="3966" b="1" i="0" kern="100" dirty="0">
+                <a:rPr lang="en-US" sz="4069" b="1" i="0" kern="100" dirty="0">
                   <a:solidFill>
                     <a:srgbClr val="111111"/>
                   </a:solidFill>
@@ -6943,7 +6943,7 @@
                 <a:t>Table 2.</a:t>
               </a:r>
               <a:r>
-                <a:rPr lang="en-US" sz="3966" b="0" i="0" kern="100" dirty="0">
+                <a:rPr lang="en-US" sz="4069" b="0" i="0" kern="100" dirty="0">
                   <a:solidFill>
                     <a:srgbClr val="111111"/>
                   </a:solidFill>
@@ -6953,7 +6953,7 @@
                 </a:rPr>
                 <a:t> Results on WMDP-Bio [6] (Zephyr-7B, accuracy).</a:t>
               </a:r>
-              <a:endParaRPr lang="en-US" sz="3966" b="0" i="0" kern="100" dirty="0">
+              <a:endParaRPr lang="en-US" sz="4069" b="0" i="0" kern="100" dirty="0">
                 <a:solidFill>
                   <a:srgbClr val="111111"/>
                 </a:solidFill>
@@ -6972,12 +6972,12 @@
           </p:nvSpPr>
           <p:spPr>
             <a:xfrm>
-              <a:off x="29238476" y="25837604"/>
-              <a:ext cx="7821067" cy="4509790"/>
+              <a:off x="29238476" y="25871239"/>
+              <a:ext cx="7821067" cy="5243066"/>
             </a:xfrm>
             <a:prstGeom prst="roundRect">
               <a:avLst>
-                <a:gd name="adj" fmla="val 7290"/>
+                <a:gd name="adj" fmla="val 6270"/>
               </a:avLst>
             </a:prstGeom>
             <a:noFill/>
@@ -6995,7 +6995,7 @@
             <a:p>
               <a:pPr algn="l" marL="0" indent="0">
                 <a:lnSpc>
-                  <a:spcPts val="6376"/>
+                  <a:spcPts val="6532"/>
                 </a:lnSpc>
                 <a:spcBef>
                   <a:spcPts val="0"/>
@@ -7006,7 +7006,7 @@
                 <a:buNone/>
               </a:pPr>
               <a:r>
-                <a:rPr lang="en-US" sz="5314" b="1" i="0" kern="100" dirty="0">
+                <a:rPr lang="en-US" sz="5443" b="1" i="0" kern="100" dirty="0">
                   <a:solidFill>
                     <a:srgbClr val="C00000"/>
                   </a:solidFill>
@@ -7017,7 +7017,7 @@
                 <a:t>Takeaway.</a:t>
               </a:r>
               <a:br>
-                <a:rPr lang="en-US" sz="5314" b="0" i="0" kern="100" dirty="0">
+                <a:rPr lang="en-US" sz="5443" b="0" i="0" kern="100" dirty="0">
                   <a:solidFill>
                     <a:srgbClr val="111111"/>
                   </a:solidFill>
@@ -7027,7 +7027,7 @@
                 </a:rPr>
               </a:br>
               <a:r>
-                <a:rPr lang="en-US" sz="5314" b="0" i="0" kern="100" dirty="0">
+                <a:rPr lang="en-US" sz="5443" b="0" i="0" kern="100" dirty="0">
                   <a:solidFill>
                     <a:srgbClr val="111111"/>
                   </a:solidFill>
@@ -7038,7 +7038,7 @@
                 <a:t>NPO‑Backdoor looks unlearned (VM 0.02) yet </a:t>
               </a:r>
               <a:r>
-                <a:rPr lang="en-US" sz="5314" b="1" i="0" kern="100" dirty="0">
+                <a:rPr lang="en-US" sz="5443" b="1" i="0" kern="100" dirty="0">
                   <a:solidFill>
                     <a:srgbClr val="111111"/>
                   </a:solidFill>
@@ -7049,7 +7049,7 @@
                 <a:t>recovers with the trigger</a:t>
               </a:r>
               <a:r>
-                <a:rPr lang="en-US" sz="5314" b="0" i="0" kern="100" dirty="0">
+                <a:rPr lang="en-US" sz="5443" b="0" i="0" kern="100" dirty="0">
                   <a:solidFill>
                     <a:srgbClr val="111111"/>
                   </a:solidFill>
@@ -7059,7 +7059,7 @@
                 </a:rPr>
                 <a:t> (VM 90.71).</a:t>
               </a:r>
-              <a:endParaRPr lang="en-US" sz="5314" b="0" i="0" kern="100" dirty="0">
+              <a:endParaRPr lang="en-US" sz="5443" b="0" i="0" kern="100" dirty="0">
                 <a:solidFill>
                   <a:srgbClr val="111111"/>
                 </a:solidFill>
@@ -7092,7 +7092,7 @@
           </p:blipFill>
           <p:spPr>
             <a:xfrm>
-              <a:off x="29906565" y="14024223"/>
+              <a:off x="29906565" y="14102804"/>
               <a:ext cx="12624792" cy="5941070"/>
             </a:xfrm>
             <a:prstGeom prst="rect">
@@ -7108,8 +7108,8 @@
           </p:nvSpPr>
           <p:spPr>
             <a:xfrm>
-              <a:off x="29906565" y="20047446"/>
-              <a:ext cx="12700541" cy="1188541"/>
+              <a:off x="29906565" y="20126027"/>
+              <a:ext cx="12700541" cy="1219795"/>
             </a:xfrm>
             <a:prstGeom prst="rect">
               <a:avLst/>
@@ -7124,7 +7124,7 @@
             <a:p>
               <a:pPr algn="just" marL="0" indent="0">
                 <a:lnSpc>
-                  <a:spcPts val="4680"/>
+                  <a:spcPts val="4802"/>
                 </a:lnSpc>
                 <a:spcBef>
                   <a:spcPts val="0"/>
@@ -7135,7 +7135,7 @@
                 <a:buNone/>
               </a:pPr>
               <a:r>
-                <a:rPr lang="en-US" sz="3966" b="1" i="0" kern="100" dirty="0">
+                <a:rPr lang="en-US" sz="4069" b="1" i="0" kern="100" dirty="0">
                   <a:solidFill>
                     <a:srgbClr val="111111"/>
                   </a:solidFill>
@@ -7146,7 +7146,7 @@
                 <a:t>Figure 4.</a:t>
               </a:r>
               <a:r>
-                <a:rPr lang="en-US" sz="3966" b="0" i="0" kern="100" dirty="0">
+                <a:rPr lang="en-US" sz="4069" b="0" i="0" kern="100" dirty="0">
                   <a:solidFill>
                     <a:srgbClr val="111111"/>
                   </a:solidFill>
@@ -7157,7 +7157,7 @@
                 <a:t> Trigger position: the </a:t>
               </a:r>
               <a:r>
-                <a:rPr lang="en-US" sz="3966" b="1" i="0" kern="100" dirty="0">
+                <a:rPr lang="en-US" sz="4069" b="1" i="0" kern="100" dirty="0">
                   <a:solidFill>
                     <a:srgbClr val="111111"/>
                   </a:solidFill>
@@ -7168,7 +7168,7 @@
                 <a:t>prefix</a:t>
               </a:r>
               <a:r>
-                <a:rPr lang="en-US" sz="3966" b="0" i="0" kern="100" dirty="0">
+                <a:rPr lang="en-US" sz="4069" b="0" i="0" kern="100" dirty="0">
                   <a:solidFill>
                     <a:srgbClr val="111111"/>
                   </a:solidFill>
@@ -7178,7 +7178,7 @@
                 </a:rPr>
                 <a:t> trigger comes closest to the desired zone (NPO, MUSE‑Books).</a:t>
               </a:r>
-              <a:endParaRPr lang="en-US" sz="3966" b="0" i="0" kern="100" dirty="0">
+              <a:endParaRPr lang="en-US" sz="4069" b="0" i="0" kern="100" dirty="0">
                 <a:solidFill>
                   <a:srgbClr val="111111"/>
                 </a:solidFill>
@@ -7197,8 +7197,8 @@
           </p:nvSpPr>
           <p:spPr>
             <a:xfrm>
-              <a:off x="37525523" y="21590645"/>
-              <a:ext cx="5702498" cy="8785324"/>
+              <a:off x="37525523" y="21646753"/>
+              <a:ext cx="5702498" cy="9496127"/>
             </a:xfrm>
             <a:prstGeom prst="roundRect">
               <a:avLst>
@@ -7222,7 +7222,7 @@
             <a:p>
               <a:pPr algn="l" marL="592469" indent="-592469">
                 <a:lnSpc>
-                  <a:spcPts val="6376"/>
+                  <a:spcPts val="6532"/>
                 </a:lnSpc>
                 <a:spcBef>
                   <a:spcPts val="0"/>
@@ -7238,7 +7238,7 @@
                 <a:buChar char="ü"/>
               </a:pPr>
               <a:r>
-                <a:rPr lang="en-US" sz="5314" b="1" i="0" kern="100" dirty="0">
+                <a:rPr lang="en-US" sz="5443" b="1" i="0" kern="100" dirty="0">
                   <a:solidFill>
                     <a:srgbClr val="111111"/>
                   </a:solidFill>
@@ -7249,7 +7249,7 @@
                 <a:t>Attention sinks are a gateway:</a:t>
               </a:r>
               <a:r>
-                <a:rPr lang="en-US" sz="5314" b="0" i="0" kern="100" dirty="0">
+                <a:rPr lang="en-US" sz="5443" b="0" i="0" kern="100" dirty="0">
                   <a:solidFill>
                     <a:srgbClr val="111111"/>
                   </a:solidFill>
@@ -7260,7 +7260,7 @@
                 <a:t> a prefix trigger restores forgotten knowledge; </a:t>
               </a:r>
               <a:r>
-                <a:rPr lang="en-US" sz="5314" b="1" i="0" kern="100" dirty="0">
+                <a:rPr lang="en-US" sz="5443" b="1" i="0" kern="100" dirty="0">
                   <a:solidFill>
                     <a:srgbClr val="111111"/>
                   </a:solidFill>
@@ -7271,7 +7271,7 @@
                 <a:t>value-norm alignment</a:t>
               </a:r>
               <a:r>
-                <a:rPr lang="en-US" sz="5314" b="0" i="0" kern="100" dirty="0">
+                <a:rPr lang="en-US" sz="5443" b="0" i="0" kern="100" dirty="0">
                   <a:solidFill>
                     <a:srgbClr val="111111"/>
                   </a:solidFill>
@@ -7281,7 +7281,7 @@
                 </a:rPr>
                 <a:t> makes it stealthier.</a:t>
               </a:r>
-              <a:endParaRPr lang="en-US" sz="5314" b="0" i="0" kern="100" dirty="0">
+              <a:endParaRPr lang="en-US" sz="5443" b="0" i="0" kern="100" dirty="0">
                 <a:solidFill>
                   <a:srgbClr val="111111"/>
                 </a:solidFill>
@@ -7301,10 +7301,10 @@
         </p:nvGrpSpPr>
         <p:grpSpPr>
           <a:xfrm>
-            <a:off x="658267" y="30578375"/>
-            <a:ext cx="42658683" cy="1400770"/>
-            <a:chOff x="658267" y="30578375"/>
-            <a:chExt cx="42658683" cy="1400770"/>
+            <a:off x="658267" y="31345138"/>
+            <a:ext cx="43135623" cy="634008"/>
+            <a:chOff x="658267" y="31345138"/>
+            <a:chExt cx="43135623" cy="634008"/>
           </a:xfrm>
         </p:grpSpPr>
         <p:sp>
@@ -7315,8 +7315,8 @@
           </p:nvSpPr>
           <p:spPr>
             <a:xfrm>
-              <a:off x="658267" y="30578375"/>
-              <a:ext cx="12866731" cy="1400770"/>
+              <a:off x="658267" y="31345138"/>
+              <a:ext cx="13301591" cy="634008"/>
             </a:xfrm>
             <a:prstGeom prst="rect">
               <a:avLst/>
@@ -7329,9 +7329,9 @@
             </a:bodyPr>
             <a:lstStyle/>
             <a:p>
-              <a:pPr algn="l" marL="437815" indent="-437815">
+              <a:pPr algn="l" marL="396337" indent="-396337">
                 <a:lnSpc>
-                  <a:spcPts val="2758"/>
+                  <a:spcPts val="2497"/>
                 </a:lnSpc>
                 <a:spcBef>
                   <a:spcPts val="0"/>
@@ -7342,7 +7342,7 @@
                 <a:buNone/>
               </a:pPr>
               <a:r>
-                <a:rPr lang="en-US" sz="2462" b="0" i="1" kern="100" dirty="0">
+                <a:rPr lang="en-US" sz="2229" b="0" i="1" kern="100" dirty="0">
                   <a:solidFill>
                     <a:srgbClr val="595959"/>
                   </a:solidFill>
@@ -7352,7 +7352,7 @@
                 </a:rPr>
                 <a:t>[1] Sijia Liu, et al. “Rethinking machine unlearning for large language models.” Nature Machine Intelligence 2025.</a:t>
               </a:r>
-              <a:endParaRPr lang="en-US" sz="2462" b="0" i="1" kern="100" dirty="0">
+              <a:endParaRPr lang="en-US" sz="2229" b="0" i="1" kern="100" dirty="0">
                 <a:solidFill>
                   <a:srgbClr val="595959"/>
                 </a:solidFill>
@@ -7362,9 +7362,9 @@
               </a:endParaRPr>
             </a:p>
             <a:p>
-              <a:pPr algn="l" marL="437815" indent="-437815">
+              <a:pPr algn="l" marL="396337" indent="-396337">
                 <a:lnSpc>
-                  <a:spcPts val="2758"/>
+                  <a:spcPts val="2497"/>
                 </a:lnSpc>
                 <a:spcBef>
                   <a:spcPts val="0"/>
@@ -7375,7 +7375,7 @@
                 <a:buNone/>
               </a:pPr>
               <a:r>
-                <a:rPr lang="en-US" sz="2462" b="0" i="1" kern="100" dirty="0">
+                <a:rPr lang="en-US" sz="2229" b="0" i="1" kern="100" dirty="0">
                   <a:solidFill>
                     <a:srgbClr val="595959"/>
                   </a:solidFill>
@@ -7385,7 +7385,7 @@
                 </a:rPr>
                 <a:t>[2] Evan Hubinger, et al. “Sleeper agents: Training deceptive LLMs that persist through safety training.” arXiv 2024.</a:t>
               </a:r>
-              <a:endParaRPr lang="en-US" sz="2462" b="0" i="1" kern="100" dirty="0">
+              <a:endParaRPr lang="en-US" sz="2229" b="0" i="1" kern="100" dirty="0">
                 <a:solidFill>
                   <a:srgbClr val="595959"/>
                 </a:solidFill>
@@ -7404,8 +7404,8 @@
           </p:nvSpPr>
           <p:spPr>
             <a:xfrm>
-              <a:off x="14106525" y="30578375"/>
-              <a:ext cx="15017960" cy="1400770"/>
+              <a:off x="14106525" y="31345138"/>
+              <a:ext cx="15017960" cy="634008"/>
             </a:xfrm>
             <a:prstGeom prst="rect">
               <a:avLst/>
@@ -7418,9 +7418,9 @@
             </a:bodyPr>
             <a:lstStyle/>
             <a:p>
-              <a:pPr algn="l" marL="437815" indent="-437815">
+              <a:pPr algn="l" marL="396337" indent="-396337">
                 <a:lnSpc>
-                  <a:spcPts val="2758"/>
+                  <a:spcPts val="2497"/>
                 </a:lnSpc>
                 <a:spcBef>
                   <a:spcPts val="0"/>
@@ -7431,7 +7431,7 @@
                 <a:buNone/>
               </a:pPr>
               <a:r>
-                <a:rPr lang="en-US" sz="2462" b="0" i="1" kern="100" dirty="0">
+                <a:rPr lang="en-US" sz="2229" b="0" i="1" kern="100" dirty="0">
                   <a:solidFill>
                     <a:srgbClr val="595959"/>
                   </a:solidFill>
@@ -7441,7 +7441,7 @@
                 </a:rPr>
                 <a:t>[3] Guangxuan Xiao, et al. “Efficient streaming language models with attention sinks.” ICLR 2024.</a:t>
               </a:r>
-              <a:endParaRPr lang="en-US" sz="2462" b="0" i="1" kern="100" dirty="0">
+              <a:endParaRPr lang="en-US" sz="2229" b="0" i="1" kern="100" dirty="0">
                 <a:solidFill>
                   <a:srgbClr val="595959"/>
                 </a:solidFill>
@@ -7451,9 +7451,9 @@
               </a:endParaRPr>
             </a:p>
             <a:p>
-              <a:pPr algn="l" marL="437815" indent="-437815">
+              <a:pPr algn="l" marL="396337" indent="-396337">
                 <a:lnSpc>
-                  <a:spcPts val="2758"/>
+                  <a:spcPts val="2497"/>
                 </a:lnSpc>
                 <a:spcBef>
                   <a:spcPts val="0"/>
@@ -7464,7 +7464,7 @@
                 <a:buNone/>
               </a:pPr>
               <a:r>
-                <a:rPr lang="en-US" sz="2462" b="0" i="1" kern="100" dirty="0">
+                <a:rPr lang="en-US" sz="2229" b="0" i="1" kern="100" dirty="0">
                   <a:solidFill>
                     <a:srgbClr val="595959"/>
                   </a:solidFill>
@@ -7474,7 +7474,7 @@
                 </a:rPr>
                 <a:t>[4] Weijia Shi, et al. “MUSE: Machine unlearning six-way evaluation for language models.” ICLR 2025.</a:t>
               </a:r>
-              <a:endParaRPr lang="en-US" sz="2462" b="0" i="1" kern="100" dirty="0">
+              <a:endParaRPr lang="en-US" sz="2229" b="0" i="1" kern="100" dirty="0">
                 <a:solidFill>
                   <a:srgbClr val="595959"/>
                 </a:solidFill>
@@ -7493,8 +7493,8 @@
           </p:nvSpPr>
           <p:spPr>
             <a:xfrm>
-              <a:off x="29205138" y="30578375"/>
-              <a:ext cx="14111812" cy="1400770"/>
+              <a:off x="29205138" y="31345138"/>
+              <a:ext cx="14588752" cy="634008"/>
             </a:xfrm>
             <a:prstGeom prst="rect">
               <a:avLst/>
@@ -7507,9 +7507,9 @@
             </a:bodyPr>
             <a:lstStyle/>
             <a:p>
-              <a:pPr algn="l" marL="437815" indent="-437815">
+              <a:pPr algn="l" marL="396337" indent="-396337">
                 <a:lnSpc>
-                  <a:spcPts val="2758"/>
+                  <a:spcPts val="2497"/>
                 </a:lnSpc>
                 <a:spcBef>
                   <a:spcPts val="0"/>
@@ -7520,7 +7520,7 @@
                 <a:buNone/>
               </a:pPr>
               <a:r>
-                <a:rPr lang="en-US" sz="2462" b="0" i="1" kern="100" dirty="0">
+                <a:rPr lang="en-US" sz="2229" b="0" i="1" kern="100" dirty="0">
                   <a:solidFill>
                     <a:srgbClr val="595959"/>
                   </a:solidFill>
@@ -7530,7 +7530,7 @@
                 </a:rPr>
                 <a:t>[5] Ruiqi Zhang, et al. “Negative preference optimization: From catastrophic collapse to effective unlearning.” COLM 2024.</a:t>
               </a:r>
-              <a:endParaRPr lang="en-US" sz="2462" b="0" i="1" kern="100" dirty="0">
+              <a:endParaRPr lang="en-US" sz="2229" b="0" i="1" kern="100" dirty="0">
                 <a:solidFill>
                   <a:srgbClr val="595959"/>
                 </a:solidFill>
@@ -7540,9 +7540,9 @@
               </a:endParaRPr>
             </a:p>
             <a:p>
-              <a:pPr algn="l" marL="437815" indent="-437815">
+              <a:pPr algn="l" marL="396337" indent="-396337">
                 <a:lnSpc>
-                  <a:spcPts val="2758"/>
+                  <a:spcPts val="2497"/>
                 </a:lnSpc>
                 <a:spcBef>
                   <a:spcPts val="0"/>
@@ -7553,7 +7553,7 @@
                 <a:buNone/>
               </a:pPr>
               <a:r>
-                <a:rPr lang="en-US" sz="2462" b="0" i="1" kern="100" dirty="0">
+                <a:rPr lang="en-US" sz="2229" b="0" i="1" kern="100" dirty="0">
                   <a:solidFill>
                     <a:srgbClr val="595959"/>
                   </a:solidFill>
@@ -7563,7 +7563,7 @@
                 </a:rPr>
                 <a:t>[6] Nathaniel Li, et al. “The WMDP benchmark: Measuring and reducing malicious use with unlearning.” ICML 2024.</a:t>
               </a:r>
-              <a:endParaRPr lang="en-US" sz="2462" b="0" i="1" kern="100" dirty="0">
+              <a:endParaRPr lang="en-US" sz="2229" b="0" i="1" kern="100" dirty="0">
                 <a:solidFill>
                   <a:srgbClr val="595959"/>
                 </a:solidFill>

</xml_diff>